<commit_message>
alinha narrativa dos materiais das aulas 1 a 3
</commit_message>
<xml_diff>
--- a/slides/A01-o-incidente-que-parou-a-linha/fonte/A01-o-incidente-que-parou-a-linha.pptx
+++ b/slides/A01-o-incidente-que-parou-a-linha/fonte/A01-o-incidente-que-parou-a-linha.pptx
@@ -1795,31 +1795,33 @@
         </p:nvSpPr>
         <p:spPr>
           <a:xfrm>
-            <a:off x="749808" y="3063240"/>
-            <a:ext cx="6675120" cy="960120"/>
-          </a:xfrm>
-          <a:prstGeom prst="rect">
-            <a:avLst/>
-          </a:prstGeom>
-          <a:noFill/>
-          <a:ln/>
-        </p:spPr>
-        <p:txBody>
-          <a:bodyPr wrap="square" lIns="0" tIns="0" rIns="0" bIns="0" rtlCol="0" anchor="ctr"/>
+            <a:off x="749808" y="2907792"/>
+            <a:ext cx="6675120" cy="1298448"/>
+          </a:xfrm>
+          <a:prstGeom prst="rect">
+            <a:avLst/>
+          </a:prstGeom>
+          <a:noFill/>
+          <a:ln/>
+        </p:spPr>
+        <p:txBody>
+          <a:bodyPr wrap="square" lIns="0" tIns="0" rIns="0" bIns="0" rtlCol="0" anchor="ctr">
+            <a:normAutofit/>
+          </a:bodyPr>
           <a:lstStyle/>
           <a:p>
             <a:pPr indent="0" marL="0">
               <a:buNone/>
             </a:pPr>
             <a:r>
-              <a:rPr lang="en-US" sz="2200" dirty="0">
+              <a:rPr lang="en-US" sz="1900" dirty="0">
                 <a:solidFill>
                   <a:srgbClr val="E6EEF5"/>
                 </a:solidFill>
               </a:rPr>
-              <a:t>Às 09:17, produção cai a zero. A rede continua respondendo. O que você pode afirmar?</a:t>
-            </a:r>
-            <a:endParaRPr lang="en-US" sz="2200" dirty="0"/>
+              <a:t>É o primeiro contato com o caso: às 09:17, a produção cai a zero, mas a rede continua respondendo. Antes de agir, precisamos separar o que foi observado do que apenas parece explicar a parada.</a:t>
+            </a:r>
+            <a:endParaRPr lang="en-US" sz="1900" dirty="0"/>
           </a:p>
         </p:txBody>
       </p:sp>

</xml_diff>